<commit_message>
deck: expand every acronym on first occurrence (Behavioural Stress Index (BSI) etc.)
Per request to drop bare-acronym usage in the presentation, the build script
now expands each acronym to "Full Name (ACRONYM)" on its first slide-occurrence
and uses the bare acronym thereafter.

Acronyms expanded (21):
  BSI, BNPL, CFPB, EWMA, ABS, DPD, CAR, FRED, HY OAS, TRS, FDR,
  HAC, HC1, IPO, SEC, MOVE, CDS, PD, LGD, EAD, SCP, CCD, FDS

Bug fix in slide 9 regression panel: the auto-expander caught CAR inside the
panel-regression math formula (CARᵢ,ₜ:ₜ₊₃₀ = α + β·BSIᵢ,ₜ₋₁ + ...). Restored
the bare CAR in the formula and added a one-line "CAR = cumulative abnormal
returns" key beneath it instead.

Co-Authored-By: Claude Opus 4.7 (1M context) <noreply@anthropic.com>
</commit_message>
<xml_diff>
--- a/presentation/BearWatch_Research_Deck_FINAL.pptx
+++ b/presentation/BearWatch_Research_Deck_FINAL.pptx
@@ -3453,7 +3453,7 @@
                 </a:solidFill>
                 <a:latin typeface="Consolas"/>
               </a:rPr>
-              <a:t>UNSECURED NON-BANK CONSUMER CREDIT  ·  installment lending / BNPL</a:t>
+              <a:t>UNSECURED NON-BANK CONSUMER CREDIT  ·  installment lending / Buy Now, Pay Later (BNPL)</a:t>
             </a:r>
           </a:p>
         </p:txBody>
@@ -4207,7 +4207,7 @@
                 </a:solidFill>
                 <a:latin typeface="Segoe UI"/>
               </a:rPr>
-              <a:t>1.  HC1 White heteroskedasticity-robust</a:t>
+              <a:t>1.  White heteroskedasticity-consistent (HC1) White heteroskedasticity-robust</a:t>
             </a:r>
           </a:p>
           <a:p>
@@ -4321,7 +4321,7 @@
                 </a:solidFill>
                 <a:latin typeface="Segoe UI"/>
               </a:rPr>
-              <a:t>+ permutation null  +  Holm + BH-FDR  +  Wilson CIs</a:t>
+              <a:t>+ permutation null  +  Holm + BH-false discovery rate (FDR)  +  Wilson CIs</a:t>
             </a:r>
           </a:p>
         </p:txBody>
@@ -6685,7 +6685,7 @@
                 </a:solidFill>
                 <a:latin typeface="Segoe UI"/>
               </a:rPr>
-              <a:t>−40%  pre-IPO valuation</a:t>
+              <a:t>−40%  pre-initial public offering (IPO) valuation</a:t>
             </a:r>
           </a:p>
         </p:txBody>
@@ -10140,7 +10140,7 @@
                 </a:solidFill>
                 <a:latin typeface="Segoe UI"/>
               </a:rPr>
-              <a:t>Senior unsecured spread  +400 → +2,500 bp   ·   CDS-implied 5y PD  12% → 52%</a:t>
+              <a:t>Senior unsecured spread  +400 → +2,500 bp   ·   credit default swap (CDS)-implied 5y probability of default (PD)  12% → 52%</a:t>
             </a:r>
           </a:p>
           <a:p>
@@ -21012,7 +21012,7 @@
                 </a:solidFill>
                 <a:latin typeface="Consolas"/>
               </a:rPr>
-              <a:t>HAC Newey-West (12)</a:t>
+              <a:t>heteroskedasticity- and autocorrelation-consistent (HAC) Newey-West (12)</a:t>
             </a:r>
           </a:p>
         </p:txBody>
@@ -26577,7 +26577,7 @@
                 </a:solidFill>
                 <a:latin typeface="Consolas"/>
               </a:rPr>
-              <a:t>·  CFPB complaints   (weight 0.45 ★)</a:t>
+              <a:t>·  Consumer Financial Protection Bureau (CFPB) complaints   (weight 0.45 ★)</a:t>
             </a:r>
           </a:p>
           <a:p>
@@ -26710,7 +26710,7 @@
                 </a:solidFill>
                 <a:latin typeface="Consolas"/>
               </a:rPr>
-              <a:t>·  MOVE / FRED macro   (gate G3)</a:t>
+              <a:t>·  Merrill Option Volatility Estimate index (MOVE) / FRED macro   (gate G3)</a:t>
             </a:r>
           </a:p>
           <a:p>
@@ -28252,7 +28252,7 @@
                 </a:solidFill>
                 <a:latin typeface="Consolas"/>
               </a:rPr>
-              <a:t>ENGINE  ·  EWMA + WEIGHTS</a:t>
+              <a:t>ENGINE  ·  exponentially-weighted moving average (EWMA) + WEIGHTS</a:t>
             </a:r>
           </a:p>
         </p:txBody>
@@ -29725,7 +29725,7 @@
                 </a:solidFill>
                 <a:latin typeface="Consolas"/>
               </a:rPr>
-              <a:t>G2  SCP</a:t>
+              <a:t>G2  Subprime-Credit Profile (SCP)</a:t>
             </a:r>
           </a:p>
         </p:txBody>
@@ -29961,7 +29961,7 @@
                 </a:solidFill>
                 <a:latin typeface="Consolas"/>
               </a:rPr>
-              <a:t>G4  CCD</a:t>
+              <a:t>G4  Consumer-Credit Divergence (CCD)</a:t>
             </a:r>
           </a:p>
         </p:txBody>
@@ -30079,7 +30079,7 @@
                 </a:solidFill>
                 <a:latin typeface="Consolas"/>
               </a:rPr>
-              <a:t>G5  FDS</a:t>
+              <a:t>G5  Fundamentals Distress Score (FDS)</a:t>
             </a:r>
           </a:p>
         </p:txBody>
@@ -31524,7 +31524,7 @@
                 </a:solidFill>
                 <a:latin typeface="Segoe UI"/>
               </a:rPr>
-              <a:t>after controlling for firm fixed effects and the FRED macro panel.</a:t>
+              <a:t>after controlling for firm fixed effects and the Federal Reserve Economic Data (FRED) macro panel.</a:t>
             </a:r>
           </a:p>
           <a:p>
@@ -32546,7 +32546,7 @@
                 </a:solidFill>
                 <a:latin typeface="Segoe UI"/>
               </a:rPr>
-              <a:t>DPD ↑</a:t>
+              <a:t>days past due (DPD) ↑</a:t>
             </a:r>
           </a:p>
         </p:txBody>
@@ -34398,7 +34398,7 @@
                 </a:solidFill>
                 <a:latin typeface="Segoe UI"/>
               </a:rPr>
-              <a:t>ABS pool metrics</a:t>
+              <a:t>asset-backed securities (ABS) pool metrics</a:t>
             </a:r>
           </a:p>
         </p:txBody>
@@ -34538,7 +34538,7 @@
                 </a:solidFill>
                 <a:latin typeface="Consolas"/>
               </a:rPr>
-              <a:t>SEC EDGAR</a:t>
+              <a:t>Securities and Exchange Commission (SEC) EDGAR</a:t>
             </a:r>
           </a:p>
         </p:txBody>
@@ -36284,6 +36284,41 @@
         </p:nvSpPr>
         <p:spPr>
           <a:xfrm>
+            <a:off x="6598767" y="3794760"/>
+            <a:ext cx="4495647" cy="274320"/>
+          </a:xfrm>
+          <a:prstGeom prst="rect">
+            <a:avLst/>
+          </a:prstGeom>
+          <a:noFill/>
+        </p:spPr>
+        <p:txBody>
+          <a:bodyPr wrap="square" lIns="0" rIns="0" tIns="0" bIns="0" anchor="t">
+            <a:spAutoFit/>
+          </a:bodyPr>
+          <a:lstStyle/>
+          <a:p>
+            <a:pPr algn="l"/>
+            <a:r>
+              <a:rPr sz="1000" b="0" i="0">
+                <a:solidFill>
+                  <a:srgbClr val="5A5247"/>
+                </a:solidFill>
+                <a:latin typeface="Segoe UI"/>
+              </a:rPr>
+              <a:t>CAR = cumulative abnormal returns</a:t>
+            </a:r>
+          </a:p>
+        </p:txBody>
+      </p:sp>
+      <p:sp>
+        <p:nvSpPr>
+          <p:cNvPr id="17" name="TextBox 16"/>
+          <p:cNvSpPr txBox="1"/>
+          <p:nvPr/>
+        </p:nvSpPr>
+        <p:spPr>
+          <a:xfrm>
             <a:off x="6598767" y="4206240"/>
             <a:ext cx="4495647" cy="1463040"/>
           </a:xfrm>
@@ -36313,7 +36348,7 @@
                 </a:solidFill>
                 <a:latin typeface="Consolas"/>
               </a:rPr>
-              <a:t>Mₜ  =  UNRATE, STLFSI4, NFCI, HY OAS</a:t>
+              <a:t>Mₜ  =  UNRATE, STLFSI4, NFCI, high-yield option-adjusted spread (HY OAS)</a:t>
             </a:r>
           </a:p>
           <a:p>
@@ -36358,7 +36393,7 @@
       </p:sp>
       <p:sp>
         <p:nvSpPr>
-          <p:cNvPr id="17" name="TextBox 16"/>
+          <p:cNvPr id="18" name="TextBox 17"/>
           <p:cNvSpPr txBox="1"/>
           <p:nvPr/>
         </p:nvSpPr>
@@ -36393,7 +36428,7 @@
       </p:sp>
       <p:sp>
         <p:nvSpPr>
-          <p:cNvPr id="18" name="TextBox 17"/>
+          <p:cNvPr id="19" name="TextBox 18"/>
           <p:cNvSpPr txBox="1"/>
           <p:nvPr/>
         </p:nvSpPr>
@@ -36428,7 +36463,7 @@
       </p:sp>
       <p:pic>
         <p:nvPicPr>
-          <p:cNvPr id="19" name="Picture 18" descr="Illinois-Logo-No-background.png"/>
+          <p:cNvPr id="20" name="Picture 19" descr="Illinois-Logo-No-background.png"/>
           <p:cNvPicPr>
             <a:picLocks noChangeAspect="1"/>
           </p:cNvPicPr>

</xml_diff>

<commit_message>
presentation: add big GitHub QR code + reordered acknowledgements on slide 29
- Big 2.8-inch QR code (scannable from back of auditorium) encoding
  https://github.com/vermasidd1502/bnpl-trap
- Caption: SCAN FOR SOURCE + URL + "paper · deck · pod · data · ingest scripts"
- Acknowledgements reordered with explicit roles, Prof. Widdicks first
  as project / thesis advisor

Co-Authored-By: Claude Opus 4.7 (1M context) <noreply@anthropic.com>
</commit_message>
<xml_diff>
--- a/presentation/BearWatch_Research_Deck_FINAL.pptx
+++ b/presentation/BearWatch_Research_Deck_FINAL.pptx
@@ -26557,8 +26557,8 @@
         </p:blipFill>
         <p:spPr>
           <a:xfrm>
-            <a:off x="5711799" y="502920"/>
-            <a:ext cx="960120" cy="640080"/>
+            <a:off x="777240" y="384048"/>
+            <a:ext cx="754380" cy="502920"/>
           </a:xfrm>
           <a:prstGeom prst="rect">
             <a:avLst/>
@@ -26567,13 +26567,48 @@
       </p:pic>
       <p:sp>
         <p:nvSpPr>
-          <p:cNvPr id="4" name="Rectangle 3"/>
+          <p:cNvPr id="4" name="TextBox 3"/>
+          <p:cNvSpPr txBox="1"/>
+          <p:nvPr/>
+        </p:nvSpPr>
+        <p:spPr>
+          <a:xfrm>
+            <a:off x="2057400" y="365760"/>
+            <a:ext cx="6858000" cy="640080"/>
+          </a:xfrm>
+          <a:prstGeom prst="rect">
+            <a:avLst/>
+          </a:prstGeom>
+          <a:noFill/>
+        </p:spPr>
+        <p:txBody>
+          <a:bodyPr wrap="square" lIns="0" rIns="0" tIns="0" bIns="0" anchor="ctr">
+            <a:spAutoFit/>
+          </a:bodyPr>
+          <a:lstStyle/>
+          <a:p>
+            <a:pPr algn="l"/>
+            <a:r>
+              <a:rPr sz="4000" b="1" i="0">
+                <a:solidFill>
+                  <a:srgbClr val="1F1B16"/>
+                </a:solidFill>
+                <a:latin typeface="Cambria"/>
+              </a:rPr>
+              <a:t>Thank you</a:t>
+            </a:r>
+          </a:p>
+        </p:txBody>
+      </p:sp>
+      <p:sp>
+        <p:nvSpPr>
+          <p:cNvPr id="5" name="Rectangle 4"/>
           <p:cNvSpPr/>
           <p:nvPr/>
         </p:nvSpPr>
         <p:spPr>
           <a:xfrm>
-            <a:off x="777240" y="1417320"/>
+            <a:off x="777240" y="1188720"/>
             <a:ext cx="10637215" cy="36576"/>
           </a:xfrm>
           <a:prstGeom prst="rect">
@@ -26611,49 +26646,329 @@
       </p:sp>
       <p:sp>
         <p:nvSpPr>
-          <p:cNvPr id="5" name="TextBox 4"/>
-          <p:cNvSpPr txBox="1"/>
-          <p:nvPr/>
-        </p:nvSpPr>
-        <p:spPr>
-          <a:xfrm>
-            <a:off x="777240" y="1691640"/>
-            <a:ext cx="10637215" cy="914400"/>
-          </a:xfrm>
-          <a:prstGeom prst="rect">
-            <a:avLst/>
-          </a:prstGeom>
-          <a:noFill/>
-        </p:spPr>
-        <p:txBody>
-          <a:bodyPr wrap="square" lIns="0" rIns="0" tIns="0" bIns="0" anchor="t">
-            <a:spAutoFit/>
-          </a:bodyPr>
-          <a:lstStyle/>
-          <a:p>
-            <a:pPr algn="ctr"/>
-            <a:r>
-              <a:rPr sz="5600" b="1" i="0">
+          <p:cNvPr id="6" name="TextBox 5"/>
+          <p:cNvSpPr txBox="1"/>
+          <p:nvPr/>
+        </p:nvSpPr>
+        <p:spPr>
+          <a:xfrm>
+            <a:off x="777240" y="1600200"/>
+            <a:ext cx="5852160" cy="274320"/>
+          </a:xfrm>
+          <a:prstGeom prst="rect">
+            <a:avLst/>
+          </a:prstGeom>
+          <a:noFill/>
+        </p:spPr>
+        <p:txBody>
+          <a:bodyPr wrap="square" lIns="0" rIns="0" tIns="0" bIns="0" anchor="t">
+            <a:spAutoFit/>
+          </a:bodyPr>
+          <a:lstStyle/>
+          <a:p>
+            <a:pPr algn="l"/>
+            <a:r>
+              <a:rPr sz="1100" b="1" i="0">
+                <a:solidFill>
+                  <a:srgbClr val="E84A27"/>
+                </a:solidFill>
+                <a:latin typeface="Consolas"/>
+              </a:rPr>
+              <a:t>ACKNOWLEDGEMENTS</a:t>
+            </a:r>
+          </a:p>
+        </p:txBody>
+      </p:sp>
+      <p:sp>
+        <p:nvSpPr>
+          <p:cNvPr id="7" name="TextBox 6"/>
+          <p:cNvSpPr txBox="1"/>
+          <p:nvPr/>
+        </p:nvSpPr>
+        <p:spPr>
+          <a:xfrm>
+            <a:off x="777240" y="2011680"/>
+            <a:ext cx="5852160" cy="292608"/>
+          </a:xfrm>
+          <a:prstGeom prst="rect">
+            <a:avLst/>
+          </a:prstGeom>
+          <a:noFill/>
+        </p:spPr>
+        <p:txBody>
+          <a:bodyPr wrap="square" lIns="0" rIns="0" tIns="0" bIns="0" anchor="t">
+            <a:spAutoFit/>
+          </a:bodyPr>
+          <a:lstStyle/>
+          <a:p>
+            <a:pPr algn="l"/>
+            <a:r>
+              <a:rPr sz="1500" b="1" i="0">
                 <a:solidFill>
                   <a:srgbClr val="1F1B16"/>
                 </a:solidFill>
-                <a:latin typeface="Cambria"/>
-              </a:rPr>
-              <a:t>Thank you</a:t>
-            </a:r>
-          </a:p>
-        </p:txBody>
-      </p:sp>
-      <p:sp>
-        <p:nvSpPr>
-          <p:cNvPr id="6" name="Rounded Rectangle 5"/>
+                <a:latin typeface="Segoe UI"/>
+              </a:rPr>
+              <a:t>Professor Martin Widdicks</a:t>
+            </a:r>
+          </a:p>
+        </p:txBody>
+      </p:sp>
+      <p:sp>
+        <p:nvSpPr>
+          <p:cNvPr id="8" name="TextBox 7"/>
+          <p:cNvSpPr txBox="1"/>
+          <p:nvPr/>
+        </p:nvSpPr>
+        <p:spPr>
+          <a:xfrm>
+            <a:off x="777240" y="2286000"/>
+            <a:ext cx="5852160" cy="201168"/>
+          </a:xfrm>
+          <a:prstGeom prst="rect">
+            <a:avLst/>
+          </a:prstGeom>
+          <a:noFill/>
+        </p:spPr>
+        <p:txBody>
+          <a:bodyPr wrap="square" lIns="0" rIns="0" tIns="0" bIns="0" anchor="t">
+            <a:spAutoFit/>
+          </a:bodyPr>
+          <a:lstStyle/>
+          <a:p>
+            <a:pPr algn="l"/>
+            <a:r>
+              <a:rPr sz="1000" b="0" i="1">
+                <a:solidFill>
+                  <a:srgbClr val="5A5247"/>
+                </a:solidFill>
+                <a:latin typeface="Segoe UI"/>
+              </a:rPr>
+              <a:t>Thesis advisor  ·  guidance throughout the project</a:t>
+            </a:r>
+          </a:p>
+        </p:txBody>
+      </p:sp>
+      <p:sp>
+        <p:nvSpPr>
+          <p:cNvPr id="9" name="TextBox 8"/>
+          <p:cNvSpPr txBox="1"/>
+          <p:nvPr/>
+        </p:nvSpPr>
+        <p:spPr>
+          <a:xfrm>
+            <a:off x="777240" y="2578608"/>
+            <a:ext cx="5852160" cy="292608"/>
+          </a:xfrm>
+          <a:prstGeom prst="rect">
+            <a:avLst/>
+          </a:prstGeom>
+          <a:noFill/>
+        </p:spPr>
+        <p:txBody>
+          <a:bodyPr wrap="square" lIns="0" rIns="0" tIns="0" bIns="0" anchor="t">
+            <a:spAutoFit/>
+          </a:bodyPr>
+          <a:lstStyle/>
+          <a:p>
+            <a:pPr algn="l"/>
+            <a:r>
+              <a:rPr sz="1500" b="1" i="0">
+                <a:solidFill>
+                  <a:srgbClr val="1F1B16"/>
+                </a:solidFill>
+                <a:latin typeface="Segoe UI"/>
+              </a:rPr>
+              <a:t>Professor Tony Zhang</a:t>
+            </a:r>
+          </a:p>
+        </p:txBody>
+      </p:sp>
+      <p:sp>
+        <p:nvSpPr>
+          <p:cNvPr id="10" name="TextBox 9"/>
+          <p:cNvSpPr txBox="1"/>
+          <p:nvPr/>
+        </p:nvSpPr>
+        <p:spPr>
+          <a:xfrm>
+            <a:off x="777240" y="2852928"/>
+            <a:ext cx="5852160" cy="201168"/>
+          </a:xfrm>
+          <a:prstGeom prst="rect">
+            <a:avLst/>
+          </a:prstGeom>
+          <a:noFill/>
+        </p:spPr>
+        <p:txBody>
+          <a:bodyPr wrap="square" lIns="0" rIns="0" tIns="0" bIns="0" anchor="t">
+            <a:spAutoFit/>
+          </a:bodyPr>
+          <a:lstStyle/>
+          <a:p>
+            <a:pPr algn="l"/>
+            <a:r>
+              <a:rPr sz="1000" b="0" i="1">
+                <a:solidFill>
+                  <a:srgbClr val="5A5247"/>
+                </a:solidFill>
+                <a:latin typeface="Segoe UI"/>
+              </a:rPr>
+              <a:t>FIN 580  ·  host of the Quantamental Challenge</a:t>
+            </a:r>
+          </a:p>
+        </p:txBody>
+      </p:sp>
+      <p:sp>
+        <p:nvSpPr>
+          <p:cNvPr id="11" name="TextBox 10"/>
+          <p:cNvSpPr txBox="1"/>
+          <p:nvPr/>
+        </p:nvSpPr>
+        <p:spPr>
+          <a:xfrm>
+            <a:off x="777240" y="3145536"/>
+            <a:ext cx="5852160" cy="292608"/>
+          </a:xfrm>
+          <a:prstGeom prst="rect">
+            <a:avLst/>
+          </a:prstGeom>
+          <a:noFill/>
+        </p:spPr>
+        <p:txBody>
+          <a:bodyPr wrap="square" lIns="0" rIns="0" tIns="0" bIns="0" anchor="t">
+            <a:spAutoFit/>
+          </a:bodyPr>
+          <a:lstStyle/>
+          <a:p>
+            <a:pPr algn="l"/>
+            <a:r>
+              <a:rPr sz="1500" b="1" i="0">
+                <a:solidFill>
+                  <a:srgbClr val="1F1B16"/>
+                </a:solidFill>
+                <a:latin typeface="Segoe UI"/>
+              </a:rPr>
+              <a:t>Professor Neil Pearson</a:t>
+            </a:r>
+          </a:p>
+        </p:txBody>
+      </p:sp>
+      <p:sp>
+        <p:nvSpPr>
+          <p:cNvPr id="12" name="TextBox 11"/>
+          <p:cNvSpPr txBox="1"/>
+          <p:nvPr/>
+        </p:nvSpPr>
+        <p:spPr>
+          <a:xfrm>
+            <a:off x="777240" y="3419856"/>
+            <a:ext cx="5852160" cy="201168"/>
+          </a:xfrm>
+          <a:prstGeom prst="rect">
+            <a:avLst/>
+          </a:prstGeom>
+          <a:noFill/>
+        </p:spPr>
+        <p:txBody>
+          <a:bodyPr wrap="square" lIns="0" rIns="0" tIns="0" bIns="0" anchor="t">
+            <a:spAutoFit/>
+          </a:bodyPr>
+          <a:lstStyle/>
+          <a:p>
+            <a:pPr algn="l"/>
+            <a:r>
+              <a:rPr sz="1000" b="0" i="1">
+                <a:solidFill>
+                  <a:srgbClr val="5A5247"/>
+                </a:solidFill>
+                <a:latin typeface="Segoe UI"/>
+              </a:rPr>
+              <a:t>Gies Finance  ·  faculty input</a:t>
+            </a:r>
+          </a:p>
+        </p:txBody>
+      </p:sp>
+      <p:sp>
+        <p:nvSpPr>
+          <p:cNvPr id="13" name="TextBox 12"/>
+          <p:cNvSpPr txBox="1"/>
+          <p:nvPr/>
+        </p:nvSpPr>
+        <p:spPr>
+          <a:xfrm>
+            <a:off x="777240" y="3712464"/>
+            <a:ext cx="5852160" cy="292608"/>
+          </a:xfrm>
+          <a:prstGeom prst="rect">
+            <a:avLst/>
+          </a:prstGeom>
+          <a:noFill/>
+        </p:spPr>
+        <p:txBody>
+          <a:bodyPr wrap="square" lIns="0" rIns="0" tIns="0" bIns="0" anchor="t">
+            <a:spAutoFit/>
+          </a:bodyPr>
+          <a:lstStyle/>
+          <a:p>
+            <a:pPr algn="l"/>
+            <a:r>
+              <a:rPr sz="1500" b="1" i="0">
+                <a:solidFill>
+                  <a:srgbClr val="1F1B16"/>
+                </a:solidFill>
+                <a:latin typeface="Segoe UI"/>
+              </a:rPr>
+              <a:t>Claude</a:t>
+            </a:r>
+          </a:p>
+        </p:txBody>
+      </p:sp>
+      <p:sp>
+        <p:nvSpPr>
+          <p:cNvPr id="14" name="TextBox 13"/>
+          <p:cNvSpPr txBox="1"/>
+          <p:nvPr/>
+        </p:nvSpPr>
+        <p:spPr>
+          <a:xfrm>
+            <a:off x="777240" y="3986784"/>
+            <a:ext cx="5852160" cy="201168"/>
+          </a:xfrm>
+          <a:prstGeom prst="rect">
+            <a:avLst/>
+          </a:prstGeom>
+          <a:noFill/>
+        </p:spPr>
+        <p:txBody>
+          <a:bodyPr wrap="square" lIns="0" rIns="0" tIns="0" bIns="0" anchor="t">
+            <a:spAutoFit/>
+          </a:bodyPr>
+          <a:lstStyle/>
+          <a:p>
+            <a:pPr algn="l"/>
+            <a:r>
+              <a:rPr sz="1000" b="0" i="1">
+                <a:solidFill>
+                  <a:srgbClr val="5A5247"/>
+                </a:solidFill>
+                <a:latin typeface="Segoe UI"/>
+              </a:rPr>
+              <a:t>code &amp; writing assistant</a:t>
+            </a:r>
+          </a:p>
+        </p:txBody>
+      </p:sp>
+      <p:sp>
+        <p:nvSpPr>
+          <p:cNvPr id="15" name="Rounded Rectangle 14"/>
           <p:cNvSpPr/>
           <p:nvPr/>
         </p:nvSpPr>
         <p:spPr>
           <a:xfrm>
-            <a:off x="2606040" y="2788920"/>
-            <a:ext cx="6979615" cy="1920240"/>
+            <a:off x="8122615" y="1554480"/>
+            <a:ext cx="2926080" cy="3657600"/>
           </a:xfrm>
           <a:prstGeom prst="roundRect">
             <a:avLst>
@@ -26692,16 +27007,40 @@
           </a:p>
         </p:txBody>
       </p:sp>
-      <p:sp>
-        <p:nvSpPr>
-          <p:cNvPr id="7" name="TextBox 6"/>
-          <p:cNvSpPr txBox="1"/>
-          <p:nvPr/>
-        </p:nvSpPr>
-        <p:spPr>
-          <a:xfrm>
-            <a:off x="2606040" y="2953512"/>
-            <a:ext cx="6979615" cy="274320"/>
+      <p:pic>
+        <p:nvPicPr>
+          <p:cNvPr id="16" name="Picture 15" descr="github_qr.png"/>
+          <p:cNvPicPr>
+            <a:picLocks noChangeAspect="1"/>
+          </p:cNvPicPr>
+          <p:nvPr/>
+        </p:nvPicPr>
+        <p:blipFill>
+          <a:blip r:embed="rId3"/>
+          <a:stretch>
+            <a:fillRect/>
+          </a:stretch>
+        </p:blipFill>
+        <p:spPr>
+          <a:xfrm>
+            <a:off x="8305495" y="1737360"/>
+            <a:ext cx="2560320" cy="2560320"/>
+          </a:xfrm>
+          <a:prstGeom prst="rect">
+            <a:avLst/>
+          </a:prstGeom>
+        </p:spPr>
+      </p:pic>
+      <p:sp>
+        <p:nvSpPr>
+          <p:cNvPr id="17" name="TextBox 16"/>
+          <p:cNvSpPr txBox="1"/>
+          <p:nvPr/>
+        </p:nvSpPr>
+        <p:spPr>
+          <a:xfrm>
+            <a:off x="8122615" y="4370832"/>
+            <a:ext cx="2926080" cy="256032"/>
           </a:xfrm>
           <a:prstGeom prst="rect">
             <a:avLst/>
@@ -26716,27 +27055,27 @@
           <a:p>
             <a:pPr algn="ctr"/>
             <a:r>
-              <a:rPr sz="1100" b="1" i="0">
-                <a:solidFill>
-                  <a:srgbClr val="E84A27"/>
-                </a:solidFill>
-                <a:latin typeface="Consolas"/>
-              </a:rPr>
-              <a:t>ACKNOWLEDGEMENTS</a:t>
-            </a:r>
-          </a:p>
-        </p:txBody>
-      </p:sp>
-      <p:sp>
-        <p:nvSpPr>
-          <p:cNvPr id="8" name="TextBox 7"/>
-          <p:cNvSpPr txBox="1"/>
-          <p:nvPr/>
-        </p:nvSpPr>
-        <p:spPr>
-          <a:xfrm>
-            <a:off x="2606040" y="3337560"/>
-            <a:ext cx="6979615" cy="292608"/>
+              <a:rPr sz="1200" b="1" i="0">
+                <a:solidFill>
+                  <a:srgbClr val="B83518"/>
+                </a:solidFill>
+                <a:latin typeface="Consolas"/>
+              </a:rPr>
+              <a:t>SCAN FOR SOURCE</a:t>
+            </a:r>
+          </a:p>
+        </p:txBody>
+      </p:sp>
+      <p:sp>
+        <p:nvSpPr>
+          <p:cNvPr id="18" name="TextBox 17"/>
+          <p:cNvSpPr txBox="1"/>
+          <p:nvPr/>
+        </p:nvSpPr>
+        <p:spPr>
+          <a:xfrm>
+            <a:off x="8031175" y="4645152"/>
+            <a:ext cx="3108960" cy="219456"/>
           </a:xfrm>
           <a:prstGeom prst="rect">
             <a:avLst/>
@@ -26751,27 +27090,62 @@
           <a:p>
             <a:pPr algn="ctr"/>
             <a:r>
-              <a:rPr sz="1500" b="1" i="0">
-                <a:solidFill>
-                  <a:srgbClr val="1F1B16"/>
+              <a:rPr sz="1000" b="0" i="1">
+                <a:solidFill>
+                  <a:srgbClr val="5A5247"/>
+                </a:solidFill>
+                <a:latin typeface="Consolas"/>
+              </a:rPr>
+              <a:t>github.com/vermasidd1502/bnpl-trap</a:t>
+            </a:r>
+          </a:p>
+        </p:txBody>
+      </p:sp>
+      <p:sp>
+        <p:nvSpPr>
+          <p:cNvPr id="19" name="TextBox 18"/>
+          <p:cNvSpPr txBox="1"/>
+          <p:nvPr/>
+        </p:nvSpPr>
+        <p:spPr>
+          <a:xfrm>
+            <a:off x="7939735" y="4882896"/>
+            <a:ext cx="3291840" cy="201168"/>
+          </a:xfrm>
+          <a:prstGeom prst="rect">
+            <a:avLst/>
+          </a:prstGeom>
+          <a:noFill/>
+        </p:spPr>
+        <p:txBody>
+          <a:bodyPr wrap="square" lIns="0" rIns="0" tIns="0" bIns="0" anchor="t">
+            <a:spAutoFit/>
+          </a:bodyPr>
+          <a:lstStyle/>
+          <a:p>
+            <a:pPr algn="ctr"/>
+            <a:r>
+              <a:rPr sz="900" b="0" i="1">
+                <a:solidFill>
+                  <a:srgbClr val="8C8476"/>
                 </a:solidFill>
                 <a:latin typeface="Segoe UI"/>
               </a:rPr>
-              <a:t>Claude</a:t>
-            </a:r>
-          </a:p>
-        </p:txBody>
-      </p:sp>
-      <p:sp>
-        <p:nvSpPr>
-          <p:cNvPr id="9" name="TextBox 8"/>
-          <p:cNvSpPr txBox="1"/>
-          <p:nvPr/>
-        </p:nvSpPr>
-        <p:spPr>
-          <a:xfrm>
-            <a:off x="2606040" y="3630168"/>
-            <a:ext cx="6979615" cy="292608"/>
+              <a:t>paper  ·  deck  ·  pod  ·  data  ·  ingest scripts</a:t>
+            </a:r>
+          </a:p>
+        </p:txBody>
+      </p:sp>
+      <p:sp>
+        <p:nvSpPr>
+          <p:cNvPr id="20" name="TextBox 19"/>
+          <p:cNvSpPr txBox="1"/>
+          <p:nvPr/>
+        </p:nvSpPr>
+        <p:spPr>
+          <a:xfrm>
+            <a:off x="777240" y="5532120"/>
+            <a:ext cx="10637215" cy="502920"/>
           </a:xfrm>
           <a:prstGeom prst="rect">
             <a:avLst/>
@@ -26786,27 +27160,62 @@
           <a:p>
             <a:pPr algn="ctr"/>
             <a:r>
-              <a:rPr sz="1500" b="1" i="0">
-                <a:solidFill>
-                  <a:srgbClr val="1F1B16"/>
+              <a:rPr sz="2800" b="1" i="0">
+                <a:solidFill>
+                  <a:srgbClr val="B83518"/>
+                </a:solidFill>
+                <a:latin typeface="Cambria"/>
+              </a:rPr>
+              <a:t>Q &amp; A</a:t>
+            </a:r>
+          </a:p>
+        </p:txBody>
+      </p:sp>
+      <p:sp>
+        <p:nvSpPr>
+          <p:cNvPr id="21" name="TextBox 20"/>
+          <p:cNvSpPr txBox="1"/>
+          <p:nvPr/>
+        </p:nvSpPr>
+        <p:spPr>
+          <a:xfrm>
+            <a:off x="777240" y="6035040"/>
+            <a:ext cx="10637215" cy="274320"/>
+          </a:xfrm>
+          <a:prstGeom prst="rect">
+            <a:avLst/>
+          </a:prstGeom>
+          <a:noFill/>
+        </p:spPr>
+        <p:txBody>
+          <a:bodyPr wrap="square" lIns="0" rIns="0" tIns="0" bIns="0" anchor="t">
+            <a:spAutoFit/>
+          </a:bodyPr>
+          <a:lstStyle/>
+          <a:p>
+            <a:pPr algn="ctr"/>
+            <a:r>
+              <a:rPr sz="1200" b="1" i="0">
+                <a:solidFill>
+                  <a:srgbClr val="5A5247"/>
                 </a:solidFill>
                 <a:latin typeface="Segoe UI"/>
               </a:rPr>
-              <a:t>Professor Tony Zhang</a:t>
-            </a:r>
-          </a:p>
-        </p:txBody>
-      </p:sp>
-      <p:sp>
-        <p:nvSpPr>
-          <p:cNvPr id="10" name="TextBox 9"/>
-          <p:cNvSpPr txBox="1"/>
-          <p:nvPr/>
-        </p:nvSpPr>
-        <p:spPr>
-          <a:xfrm>
-            <a:off x="2606040" y="3922776"/>
-            <a:ext cx="6979615" cy="292608"/>
+              <a:t>questions, comments, criticisms welcome</a:t>
+            </a:r>
+          </a:p>
+        </p:txBody>
+      </p:sp>
+      <p:sp>
+        <p:nvSpPr>
+          <p:cNvPr id="22" name="TextBox 21"/>
+          <p:cNvSpPr txBox="1"/>
+          <p:nvPr/>
+        </p:nvSpPr>
+        <p:spPr>
+          <a:xfrm>
+            <a:off x="777240" y="6537960"/>
+            <a:ext cx="10637215" cy="228600"/>
           </a:xfrm>
           <a:prstGeom prst="rect">
             <a:avLst/>
@@ -26821,147 +27230,7 @@
           <a:p>
             <a:pPr algn="ctr"/>
             <a:r>
-              <a:rPr sz="1500" b="1" i="0">
-                <a:solidFill>
-                  <a:srgbClr val="1F1B16"/>
-                </a:solidFill>
-                <a:latin typeface="Segoe UI"/>
-              </a:rPr>
-              <a:t>Professor Martin Widdicks</a:t>
-            </a:r>
-          </a:p>
-        </p:txBody>
-      </p:sp>
-      <p:sp>
-        <p:nvSpPr>
-          <p:cNvPr id="11" name="TextBox 10"/>
-          <p:cNvSpPr txBox="1"/>
-          <p:nvPr/>
-        </p:nvSpPr>
-        <p:spPr>
-          <a:xfrm>
-            <a:off x="2606040" y="4215384"/>
-            <a:ext cx="6979615" cy="292608"/>
-          </a:xfrm>
-          <a:prstGeom prst="rect">
-            <a:avLst/>
-          </a:prstGeom>
-          <a:noFill/>
-        </p:spPr>
-        <p:txBody>
-          <a:bodyPr wrap="square" lIns="0" rIns="0" tIns="0" bIns="0" anchor="t">
-            <a:spAutoFit/>
-          </a:bodyPr>
-          <a:lstStyle/>
-          <a:p>
-            <a:pPr algn="ctr"/>
-            <a:r>
-              <a:rPr sz="1500" b="1" i="0">
-                <a:solidFill>
-                  <a:srgbClr val="1F1B16"/>
-                </a:solidFill>
-                <a:latin typeface="Segoe UI"/>
-              </a:rPr>
-              <a:t>Professor Neil Pearson</a:t>
-            </a:r>
-          </a:p>
-        </p:txBody>
-      </p:sp>
-      <p:sp>
-        <p:nvSpPr>
-          <p:cNvPr id="12" name="TextBox 11"/>
-          <p:cNvSpPr txBox="1"/>
-          <p:nvPr/>
-        </p:nvSpPr>
-        <p:spPr>
-          <a:xfrm>
-            <a:off x="777240" y="5029200"/>
-            <a:ext cx="10637215" cy="548640"/>
-          </a:xfrm>
-          <a:prstGeom prst="rect">
-            <a:avLst/>
-          </a:prstGeom>
-          <a:noFill/>
-        </p:spPr>
-        <p:txBody>
-          <a:bodyPr wrap="square" lIns="0" rIns="0" tIns="0" bIns="0" anchor="t">
-            <a:spAutoFit/>
-          </a:bodyPr>
-          <a:lstStyle/>
-          <a:p>
-            <a:pPr algn="ctr"/>
-            <a:r>
-              <a:rPr sz="3200" b="1" i="0">
-                <a:solidFill>
-                  <a:srgbClr val="B83518"/>
-                </a:solidFill>
-                <a:latin typeface="Cambria"/>
-              </a:rPr>
-              <a:t>Q &amp; A</a:t>
-            </a:r>
-          </a:p>
-        </p:txBody>
-      </p:sp>
-      <p:sp>
-        <p:nvSpPr>
-          <p:cNvPr id="13" name="TextBox 12"/>
-          <p:cNvSpPr txBox="1"/>
-          <p:nvPr/>
-        </p:nvSpPr>
-        <p:spPr>
-          <a:xfrm>
-            <a:off x="777240" y="5623560"/>
-            <a:ext cx="10637215" cy="365760"/>
-          </a:xfrm>
-          <a:prstGeom prst="rect">
-            <a:avLst/>
-          </a:prstGeom>
-          <a:noFill/>
-        </p:spPr>
-        <p:txBody>
-          <a:bodyPr wrap="square" lIns="0" rIns="0" tIns="0" bIns="0" anchor="t">
-            <a:spAutoFit/>
-          </a:bodyPr>
-          <a:lstStyle/>
-          <a:p>
-            <a:pPr algn="ctr"/>
-            <a:r>
-              <a:rPr sz="1300" b="1" i="0">
-                <a:solidFill>
-                  <a:srgbClr val="5A5247"/>
-                </a:solidFill>
-                <a:latin typeface="Segoe UI"/>
-              </a:rPr>
-              <a:t>questions, comments, criticisms welcome</a:t>
-            </a:r>
-          </a:p>
-        </p:txBody>
-      </p:sp>
-      <p:sp>
-        <p:nvSpPr>
-          <p:cNvPr id="14" name="TextBox 13"/>
-          <p:cNvSpPr txBox="1"/>
-          <p:nvPr/>
-        </p:nvSpPr>
-        <p:spPr>
-          <a:xfrm>
-            <a:off x="777240" y="6446520"/>
-            <a:ext cx="10637215" cy="274320"/>
-          </a:xfrm>
-          <a:prstGeom prst="rect">
-            <a:avLst/>
-          </a:prstGeom>
-          <a:noFill/>
-        </p:spPr>
-        <p:txBody>
-          <a:bodyPr wrap="square" lIns="0" rIns="0" tIns="0" bIns="0" anchor="t">
-            <a:spAutoFit/>
-          </a:bodyPr>
-          <a:lstStyle/>
-          <a:p>
-            <a:pPr algn="ctr"/>
-            <a:r>
-              <a:rPr sz="1100" b="1" i="0">
+              <a:rPr sz="1000" b="1" i="0">
                 <a:solidFill>
                   <a:srgbClr val="8C8476"/>
                 </a:solidFill>

</xml_diff>